<commit_message>
Added final version of presentation
</commit_message>
<xml_diff>
--- a/Analiza Teoretyczna Metryki VoG.pptx
+++ b/Analiza Teoretyczna Metryki VoG.pptx
@@ -18,6 +18,7 @@
     <p:sldId id="265" r:id="rId12"/>
     <p:sldId id="260" r:id="rId13"/>
     <p:sldId id="261" r:id="rId14"/>
+    <p:sldId id="268" r:id="rId15"/>
   </p:sldIdLst>
   <p:sldSz cx="12192000" cy="6858000"/>
   <p:notesSz cx="6858000" cy="9144000"/>
@@ -1095,7 +1096,7 @@
           <a:p>
             <a:fld id="{E180F3EB-CED7-43F4-9E23-4BCBF0141284}" type="datetimeFigureOut">
               <a:rPr lang="pl-PL" smtClean="0"/>
-              <a:t>26.03.2026</a:t>
+              <a:t>27.03.2026</a:t>
             </a:fld>
             <a:endParaRPr lang="pl-PL"/>
           </a:p>
@@ -1293,7 +1294,7 @@
           <a:p>
             <a:fld id="{E180F3EB-CED7-43F4-9E23-4BCBF0141284}" type="datetimeFigureOut">
               <a:rPr lang="pl-PL" smtClean="0"/>
-              <a:t>26.03.2026</a:t>
+              <a:t>27.03.2026</a:t>
             </a:fld>
             <a:endParaRPr lang="pl-PL"/>
           </a:p>
@@ -1568,7 +1569,7 @@
           <a:p>
             <a:fld id="{E180F3EB-CED7-43F4-9E23-4BCBF0141284}" type="datetimeFigureOut">
               <a:rPr lang="pl-PL" smtClean="0"/>
-              <a:t>26.03.2026</a:t>
+              <a:t>27.03.2026</a:t>
             </a:fld>
             <a:endParaRPr lang="pl-PL"/>
           </a:p>
@@ -1833,7 +1834,7 @@
           <a:p>
             <a:fld id="{E180F3EB-CED7-43F4-9E23-4BCBF0141284}" type="datetimeFigureOut">
               <a:rPr lang="pl-PL" smtClean="0"/>
-              <a:t>26.03.2026</a:t>
+              <a:t>27.03.2026</a:t>
             </a:fld>
             <a:endParaRPr lang="pl-PL"/>
           </a:p>
@@ -2245,7 +2246,7 @@
           <a:p>
             <a:fld id="{E180F3EB-CED7-43F4-9E23-4BCBF0141284}" type="datetimeFigureOut">
               <a:rPr lang="pl-PL" smtClean="0"/>
-              <a:t>26.03.2026</a:t>
+              <a:t>27.03.2026</a:t>
             </a:fld>
             <a:endParaRPr lang="pl-PL"/>
           </a:p>
@@ -2386,7 +2387,7 @@
           <a:p>
             <a:fld id="{E180F3EB-CED7-43F4-9E23-4BCBF0141284}" type="datetimeFigureOut">
               <a:rPr lang="pl-PL" smtClean="0"/>
-              <a:t>26.03.2026</a:t>
+              <a:t>27.03.2026</a:t>
             </a:fld>
             <a:endParaRPr lang="pl-PL"/>
           </a:p>
@@ -2499,7 +2500,7 @@
           <a:p>
             <a:fld id="{E180F3EB-CED7-43F4-9E23-4BCBF0141284}" type="datetimeFigureOut">
               <a:rPr lang="pl-PL" smtClean="0"/>
-              <a:t>26.03.2026</a:t>
+              <a:t>27.03.2026</a:t>
             </a:fld>
             <a:endParaRPr lang="pl-PL"/>
           </a:p>
@@ -3008,7 +3009,7 @@
           <a:p>
             <a:fld id="{E180F3EB-CED7-43F4-9E23-4BCBF0141284}" type="datetimeFigureOut">
               <a:rPr lang="pl-PL" smtClean="0"/>
-              <a:t>26.03.2026</a:t>
+              <a:t>27.03.2026</a:t>
             </a:fld>
             <a:endParaRPr lang="pl-PL"/>
           </a:p>
@@ -3296,7 +3297,7 @@
           <a:p>
             <a:fld id="{E180F3EB-CED7-43F4-9E23-4BCBF0141284}" type="datetimeFigureOut">
               <a:rPr lang="pl-PL" smtClean="0"/>
-              <a:t>26.03.2026</a:t>
+              <a:t>27.03.2026</a:t>
             </a:fld>
             <a:endParaRPr lang="pl-PL"/>
           </a:p>
@@ -3494,7 +3495,7 @@
           <a:p>
             <a:fld id="{E180F3EB-CED7-43F4-9E23-4BCBF0141284}" type="datetimeFigureOut">
               <a:rPr lang="pl-PL" smtClean="0"/>
-              <a:t>26.03.2026</a:t>
+              <a:t>27.03.2026</a:t>
             </a:fld>
             <a:endParaRPr lang="pl-PL"/>
           </a:p>
@@ -3702,7 +3703,7 @@
           <a:p>
             <a:fld id="{E180F3EB-CED7-43F4-9E23-4BCBF0141284}" type="datetimeFigureOut">
               <a:rPr lang="pl-PL" smtClean="0"/>
-              <a:t>26.03.2026</a:t>
+              <a:t>27.03.2026</a:t>
             </a:fld>
             <a:endParaRPr lang="pl-PL"/>
           </a:p>
@@ -6317,7 +6318,7 @@
           <a:p>
             <a:fld id="{E180F3EB-CED7-43F4-9E23-4BCBF0141284}" type="datetimeFigureOut">
               <a:rPr lang="pl-PL" smtClean="0"/>
-              <a:t>26.03.2026</a:t>
+              <a:t>27.03.2026</a:t>
             </a:fld>
             <a:endParaRPr lang="pl-PL"/>
           </a:p>
@@ -6756,9 +6757,14 @@
           <a:lstStyle/>
           <a:p>
             <a:r>
-              <a:rPr lang="pl-PL"/>
-              <a:t>Analiza Teoretyczna Metryki VoG</a:t>
-            </a:r>
+              <a:rPr lang="pl-PL" dirty="0"/>
+              <a:t>Analiza Teoretyczna Metryki </a:t>
+            </a:r>
+            <a:r>
+              <a:rPr lang="pl-PL" dirty="0" err="1"/>
+              <a:t>VoG</a:t>
+            </a:r>
+            <a:endParaRPr lang="pl-PL" dirty="0"/>
           </a:p>
         </p:txBody>
       </p:sp>
@@ -6778,7 +6784,12 @@
             <p:ph type="subTitle" idx="1"/>
           </p:nvPr>
         </p:nvSpPr>
-        <p:spPr/>
+        <p:spPr>
+          <a:xfrm>
+            <a:off x="1524000" y="3602038"/>
+            <a:ext cx="9144000" cy="809028"/>
+          </a:xfrm>
+        </p:spPr>
         <p:txBody>
           <a:bodyPr/>
           <a:lstStyle/>
@@ -6786,6 +6797,122 @@
             <a:r>
               <a:rPr lang="pl-PL" dirty="0"/>
               <a:t>Matematyczna logika oceny trudności przykładów oraz oryginalny kod źródłowy</a:t>
+            </a:r>
+          </a:p>
+        </p:txBody>
+      </p:sp>
+      <p:sp>
+        <p:nvSpPr>
+          <p:cNvPr id="4" name="pole tekstowe 3">
+            <a:extLst>
+              <a:ext uri="{FF2B5EF4-FFF2-40B4-BE49-F238E27FC236}">
+                <a16:creationId xmlns:a16="http://schemas.microsoft.com/office/drawing/2014/main" id="{31A716BE-FDF7-A567-B5FD-37554978D64E}"/>
+              </a:ext>
+            </a:extLst>
+          </p:cNvPr>
+          <p:cNvSpPr txBox="1"/>
+          <p:nvPr/>
+        </p:nvSpPr>
+        <p:spPr>
+          <a:xfrm>
+            <a:off x="1524000" y="4498848"/>
+            <a:ext cx="9144000" cy="646331"/>
+          </a:xfrm>
+          <a:prstGeom prst="rect">
+            <a:avLst/>
+          </a:prstGeom>
+          <a:noFill/>
+        </p:spPr>
+        <p:txBody>
+          <a:bodyPr wrap="square" rtlCol="0">
+            <a:spAutoFit/>
+          </a:bodyPr>
+          <a:lstStyle/>
+          <a:p>
+            <a:pPr algn="ctr"/>
+            <a:r>
+              <a:rPr lang="pl-PL" dirty="0"/>
+              <a:t>Na podstawie artykułu </a:t>
+            </a:r>
+            <a:r>
+              <a:rPr lang="pl-PL" dirty="0" err="1"/>
+              <a:t>Chirag</a:t>
+            </a:r>
+            <a:r>
+              <a:rPr lang="pl-PL" dirty="0"/>
+              <a:t> </a:t>
+            </a:r>
+            <a:r>
+              <a:rPr lang="pl-PL" dirty="0" err="1"/>
+              <a:t>Agarwal</a:t>
+            </a:r>
+            <a:r>
+              <a:rPr lang="pl-PL" dirty="0"/>
+              <a:t>, Daniel </a:t>
+            </a:r>
+            <a:r>
+              <a:rPr lang="pl-PL" dirty="0" err="1"/>
+              <a:t>D’souza</a:t>
+            </a:r>
+            <a:r>
+              <a:rPr lang="pl-PL" dirty="0"/>
+              <a:t>, Sara Hooker. </a:t>
+            </a:r>
+            <a:r>
+              <a:rPr lang="pl-PL" dirty="0" err="1"/>
+              <a:t>Estimating</a:t>
+            </a:r>
+            <a:r>
+              <a:rPr lang="pl-PL" dirty="0"/>
+              <a:t> </a:t>
+            </a:r>
+            <a:r>
+              <a:rPr lang="pl-PL" dirty="0" err="1"/>
+              <a:t>Example</a:t>
+            </a:r>
+            <a:r>
+              <a:rPr lang="pl-PL" dirty="0"/>
+              <a:t> </a:t>
+            </a:r>
+            <a:r>
+              <a:rPr lang="pl-PL" dirty="0" err="1"/>
+              <a:t>Difficulty</a:t>
+            </a:r>
+            <a:r>
+              <a:rPr lang="pl-PL" dirty="0"/>
+              <a:t> </a:t>
+            </a:r>
+            <a:r>
+              <a:rPr lang="pl-PL" dirty="0" err="1"/>
+              <a:t>uding</a:t>
+            </a:r>
+            <a:r>
+              <a:rPr lang="pl-PL" dirty="0"/>
+              <a:t> </a:t>
+            </a:r>
+            <a:r>
+              <a:rPr lang="pl-PL" dirty="0" err="1"/>
+              <a:t>Variance</a:t>
+            </a:r>
+            <a:r>
+              <a:rPr lang="pl-PL" dirty="0"/>
+              <a:t> of </a:t>
+            </a:r>
+            <a:r>
+              <a:rPr lang="pl-PL" dirty="0" err="1"/>
+              <a:t>Gradients</a:t>
+            </a:r>
+            <a:r>
+              <a:rPr lang="pl-PL" dirty="0"/>
+              <a:t>. </a:t>
+            </a:r>
+            <a:r>
+              <a:rPr lang="pl-PL" i="1" dirty="0" err="1"/>
+              <a:t>arXiv</a:t>
+            </a:r>
+            <a:r>
+              <a:rPr lang="pl-PL" dirty="0"/>
+              <a:t>, 2022</a:t>
             </a:r>
           </a:p>
         </p:txBody>
@@ -7776,6 +7903,86 @@
     <p:extLst>
       <p:ext uri="{BB962C8B-B14F-4D97-AF65-F5344CB8AC3E}">
         <p14:creationId xmlns:p14="http://schemas.microsoft.com/office/powerpoint/2010/main" val="4071234729"/>
+      </p:ext>
+    </p:extLst>
+  </p:cSld>
+  <p:clrMapOvr>
+    <a:masterClrMapping/>
+  </p:clrMapOvr>
+</p:sld>
+</file>
+
+<file path=ppt/slides/slide13.xml><?xml version="1.0" encoding="utf-8"?>
+<p:sld xmlns:a="http://schemas.openxmlformats.org/drawingml/2006/main" xmlns:r="http://schemas.openxmlformats.org/officeDocument/2006/relationships" xmlns:p="http://schemas.openxmlformats.org/presentationml/2006/main">
+  <p:cSld>
+    <p:spTree>
+      <p:nvGrpSpPr>
+        <p:cNvPr id="1" name=""/>
+        <p:cNvGrpSpPr/>
+        <p:nvPr/>
+      </p:nvGrpSpPr>
+      <p:grpSpPr>
+        <a:xfrm>
+          <a:off x="0" y="0"/>
+          <a:ext cx="0" cy="0"/>
+          <a:chOff x="0" y="0"/>
+          <a:chExt cx="0" cy="0"/>
+        </a:xfrm>
+      </p:grpSpPr>
+      <p:sp>
+        <p:nvSpPr>
+          <p:cNvPr id="2" name="Tytuł 1">
+            <a:extLst>
+              <a:ext uri="{FF2B5EF4-FFF2-40B4-BE49-F238E27FC236}">
+                <a16:creationId xmlns:a16="http://schemas.microsoft.com/office/drawing/2014/main" id="{ABF6D0C4-2D0F-6670-98C9-0A2916B1761C}"/>
+              </a:ext>
+            </a:extLst>
+          </p:cNvPr>
+          <p:cNvSpPr>
+            <a:spLocks noGrp="1"/>
+          </p:cNvSpPr>
+          <p:nvPr>
+            <p:ph type="title"/>
+          </p:nvPr>
+        </p:nvSpPr>
+        <p:spPr/>
+        <p:txBody>
+          <a:bodyPr/>
+          <a:lstStyle/>
+          <a:p>
+            <a:endParaRPr lang="pl-PL" dirty="0"/>
+          </a:p>
+        </p:txBody>
+      </p:sp>
+      <p:sp>
+        <p:nvSpPr>
+          <p:cNvPr id="3" name="Symbol zastępczy tekstu 2">
+            <a:extLst>
+              <a:ext uri="{FF2B5EF4-FFF2-40B4-BE49-F238E27FC236}">
+                <a16:creationId xmlns:a16="http://schemas.microsoft.com/office/drawing/2014/main" id="{BF9FFE89-09B9-41D5-1B5B-5E78538ABD95}"/>
+              </a:ext>
+            </a:extLst>
+          </p:cNvPr>
+          <p:cNvSpPr>
+            <a:spLocks noGrp="1"/>
+          </p:cNvSpPr>
+          <p:nvPr>
+            <p:ph type="body" idx="1"/>
+          </p:nvPr>
+        </p:nvSpPr>
+        <p:spPr/>
+        <p:txBody>
+          <a:bodyPr/>
+          <a:lstStyle/>
+          <a:p>
+            <a:endParaRPr lang="pl-PL"/>
+          </a:p>
+        </p:txBody>
+      </p:sp>
+    </p:spTree>
+    <p:extLst>
+      <p:ext uri="{BB962C8B-B14F-4D97-AF65-F5344CB8AC3E}">
+        <p14:creationId xmlns:p14="http://schemas.microsoft.com/office/powerpoint/2010/main" val="1501502243"/>
       </p:ext>
     </p:extLst>
   </p:cSld>

</xml_diff>